<commit_message>
Add 'Thank You' slide to PowerPoint generator for Disease Prediction System, enhancing presentation closure with team information and discussion prompt. Updated slide builder sequence to include new slide.
</commit_message>
<xml_diff>
--- a/Disease_Prediction_PPT.pptx
+++ b/Disease_Prediction_PPT.pptx
@@ -17,6 +17,7 @@
     <p:sldId id="265" r:id="rId16"/>
     <p:sldId id="266" r:id="rId17"/>
     <p:sldId id="267" r:id="rId18"/>
+    <p:sldId id="268" r:id="rId19"/>
   </p:sldIdLst>
   <p:sldSz cx="12188952" cy="6858000" type="screen4x3"/>
   <p:notesSz cx="6858000" cy="9144000"/>
@@ -12238,6 +12239,1271 @@
 </p:sld>
 </file>
 
+<file path=ppt/slides/slide13.xml><?xml version="1.0" encoding="utf-8"?>
+<p:sld xmlns:a="http://schemas.openxmlformats.org/drawingml/2006/main" xmlns:p="http://schemas.openxmlformats.org/presentationml/2006/main" xmlns:r="http://schemas.openxmlformats.org/officeDocument/2006/relationships">
+  <p:cSld>
+    <p:bg>
+      <p:bgPr>
+        <a:solidFill>
+          <a:srgbClr val="070B14"/>
+        </a:solidFill>
+        <a:effectLst/>
+      </p:bgPr>
+    </p:bg>
+    <p:spTree>
+      <p:nvGrpSpPr>
+        <p:cNvPr id="1" name=""/>
+        <p:cNvGrpSpPr/>
+        <p:nvPr/>
+      </p:nvGrpSpPr>
+      <p:grpSpPr/>
+      <p:sp>
+        <p:nvSpPr>
+          <p:cNvPr id="2" name="Oval 1"/>
+          <p:cNvSpPr/>
+          <p:nvPr/>
+        </p:nvSpPr>
+        <p:spPr>
+          <a:xfrm>
+            <a:off x="7772400" y="-1280160"/>
+            <a:ext cx="5486400" cy="5486400"/>
+          </a:xfrm>
+          <a:prstGeom prst="ellipse">
+            <a:avLst/>
+          </a:prstGeom>
+          <a:solidFill>
+            <a:srgbClr val="401505"/>
+          </a:solidFill>
+          <a:ln>
+            <a:noFill/>
+          </a:ln>
+        </p:spPr>
+        <p:style>
+          <a:lnRef idx="1">
+            <a:schemeClr val="accent1"/>
+          </a:lnRef>
+          <a:fillRef idx="3">
+            <a:schemeClr val="accent1"/>
+          </a:fillRef>
+          <a:effectRef idx="2">
+            <a:schemeClr val="accent1"/>
+          </a:effectRef>
+          <a:fontRef idx="minor">
+            <a:schemeClr val="lt1"/>
+          </a:fontRef>
+        </p:style>
+        <p:txBody>
+          <a:bodyPr rtlCol="0" anchor="ctr"/>
+          <a:lstStyle/>
+          <a:p>
+            <a:pPr algn="ctr"/>
+          </a:p>
+        </p:txBody>
+      </p:sp>
+      <p:sp>
+        <p:nvSpPr>
+          <p:cNvPr id="3" name="Oval 2"/>
+          <p:cNvSpPr/>
+          <p:nvPr/>
+        </p:nvSpPr>
+        <p:spPr>
+          <a:xfrm>
+            <a:off x="-1097280" y="3840480"/>
+            <a:ext cx="3200400" cy="3200400"/>
+          </a:xfrm>
+          <a:prstGeom prst="ellipse">
+            <a:avLst/>
+          </a:prstGeom>
+          <a:solidFill>
+            <a:srgbClr val="082636"/>
+          </a:solidFill>
+          <a:ln>
+            <a:noFill/>
+          </a:ln>
+        </p:spPr>
+        <p:style>
+          <a:lnRef idx="1">
+            <a:schemeClr val="accent1"/>
+          </a:lnRef>
+          <a:fillRef idx="3">
+            <a:schemeClr val="accent1"/>
+          </a:fillRef>
+          <a:effectRef idx="2">
+            <a:schemeClr val="accent1"/>
+          </a:effectRef>
+          <a:fontRef idx="minor">
+            <a:schemeClr val="lt1"/>
+          </a:fontRef>
+        </p:style>
+        <p:txBody>
+          <a:bodyPr rtlCol="0" anchor="ctr"/>
+          <a:lstStyle/>
+          <a:p>
+            <a:pPr algn="ctr"/>
+          </a:p>
+        </p:txBody>
+      </p:sp>
+      <p:sp>
+        <p:nvSpPr>
+          <p:cNvPr id="4" name="Oval 3"/>
+          <p:cNvSpPr/>
+          <p:nvPr/>
+        </p:nvSpPr>
+        <p:spPr>
+          <a:xfrm>
+            <a:off x="4572000" y="4572000"/>
+            <a:ext cx="2011680" cy="2011680"/>
+          </a:xfrm>
+          <a:prstGeom prst="ellipse">
+            <a:avLst/>
+          </a:prstGeom>
+          <a:solidFill>
+            <a:srgbClr val="1A2808"/>
+          </a:solidFill>
+          <a:ln>
+            <a:noFill/>
+          </a:ln>
+        </p:spPr>
+        <p:style>
+          <a:lnRef idx="1">
+            <a:schemeClr val="accent1"/>
+          </a:lnRef>
+          <a:fillRef idx="3">
+            <a:schemeClr val="accent1"/>
+          </a:fillRef>
+          <a:effectRef idx="2">
+            <a:schemeClr val="accent1"/>
+          </a:effectRef>
+          <a:fontRef idx="minor">
+            <a:schemeClr val="lt1"/>
+          </a:fontRef>
+        </p:style>
+        <p:txBody>
+          <a:bodyPr rtlCol="0" anchor="ctr"/>
+          <a:lstStyle/>
+          <a:p>
+            <a:pPr algn="ctr"/>
+          </a:p>
+        </p:txBody>
+      </p:sp>
+      <p:sp>
+        <p:nvSpPr>
+          <p:cNvPr id="5" name="Rectangle 4"/>
+          <p:cNvSpPr/>
+          <p:nvPr/>
+        </p:nvSpPr>
+        <p:spPr>
+          <a:xfrm>
+            <a:off x="0" y="0"/>
+            <a:ext cx="12188952" cy="50292"/>
+          </a:xfrm>
+          <a:prstGeom prst="rect">
+            <a:avLst/>
+          </a:prstGeom>
+          <a:solidFill>
+            <a:srgbClr val="FF6B2B"/>
+          </a:solidFill>
+          <a:ln>
+            <a:noFill/>
+          </a:ln>
+        </p:spPr>
+        <p:style>
+          <a:lnRef idx="1">
+            <a:schemeClr val="accent1"/>
+          </a:lnRef>
+          <a:fillRef idx="3">
+            <a:schemeClr val="accent1"/>
+          </a:fillRef>
+          <a:effectRef idx="2">
+            <a:schemeClr val="accent1"/>
+          </a:effectRef>
+          <a:fontRef idx="minor">
+            <a:schemeClr val="lt1"/>
+          </a:fontRef>
+        </p:style>
+        <p:txBody>
+          <a:bodyPr rtlCol="0" anchor="ctr"/>
+          <a:lstStyle/>
+          <a:p>
+            <a:pPr algn="ctr"/>
+          </a:p>
+        </p:txBody>
+      </p:sp>
+      <p:sp>
+        <p:nvSpPr>
+          <p:cNvPr id="6" name="TextBox 5"/>
+          <p:cNvSpPr txBox="1"/>
+          <p:nvPr/>
+        </p:nvSpPr>
+        <p:spPr>
+          <a:xfrm>
+            <a:off x="457200" y="1463040"/>
+            <a:ext cx="11274552" cy="1280160"/>
+          </a:xfrm>
+          <a:prstGeom prst="rect">
+            <a:avLst/>
+          </a:prstGeom>
+          <a:noFill/>
+        </p:spPr>
+        <p:txBody>
+          <a:bodyPr wrap="square" anchor="ctr">
+            <a:noAutofit/>
+          </a:bodyPr>
+          <a:lstStyle/>
+          <a:p>
+            <a:pPr algn="ctr"/>
+            <a:r>
+              <a:rPr sz="9000" b="1" i="0">
+                <a:solidFill>
+                  <a:srgbClr val="F2F5FA"/>
+                </a:solidFill>
+                <a:latin typeface="Segoe UI Black"/>
+              </a:rPr>
+              <a:t>Thank You</a:t>
+            </a:r>
+          </a:p>
+        </p:txBody>
+      </p:sp>
+      <p:sp>
+        <p:nvSpPr>
+          <p:cNvPr id="7" name="Rectangle 6"/>
+          <p:cNvSpPr/>
+          <p:nvPr/>
+        </p:nvSpPr>
+        <p:spPr>
+          <a:xfrm>
+            <a:off x="3351276" y="2880360"/>
+            <a:ext cx="5486400" cy="64008"/>
+          </a:xfrm>
+          <a:prstGeom prst="rect">
+            <a:avLst/>
+          </a:prstGeom>
+          <a:solidFill>
+            <a:srgbClr val="FF6B2B"/>
+          </a:solidFill>
+          <a:ln>
+            <a:noFill/>
+          </a:ln>
+        </p:spPr>
+        <p:style>
+          <a:lnRef idx="1">
+            <a:schemeClr val="accent1"/>
+          </a:lnRef>
+          <a:fillRef idx="3">
+            <a:schemeClr val="accent1"/>
+          </a:fillRef>
+          <a:effectRef idx="2">
+            <a:schemeClr val="accent1"/>
+          </a:effectRef>
+          <a:fontRef idx="minor">
+            <a:schemeClr val="lt1"/>
+          </a:fontRef>
+        </p:style>
+        <p:txBody>
+          <a:bodyPr rtlCol="0" anchor="ctr"/>
+          <a:lstStyle/>
+          <a:p>
+            <a:pPr algn="ctr"/>
+          </a:p>
+        </p:txBody>
+      </p:sp>
+      <p:sp>
+        <p:nvSpPr>
+          <p:cNvPr id="8" name="TextBox 7"/>
+          <p:cNvSpPr txBox="1"/>
+          <p:nvPr/>
+        </p:nvSpPr>
+        <p:spPr>
+          <a:xfrm>
+            <a:off x="457200" y="3090672"/>
+            <a:ext cx="11274552" cy="365760"/>
+          </a:xfrm>
+          <a:prstGeom prst="rect">
+            <a:avLst/>
+          </a:prstGeom>
+          <a:noFill/>
+        </p:spPr>
+        <p:txBody>
+          <a:bodyPr wrap="square" anchor="ctr">
+            <a:noAutofit/>
+          </a:bodyPr>
+          <a:lstStyle/>
+          <a:p>
+            <a:pPr algn="ctr"/>
+            <a:r>
+              <a:rPr sz="1600" b="0" i="0">
+                <a:solidFill>
+                  <a:srgbClr val="8A94A6"/>
+                </a:solidFill>
+                <a:latin typeface="Segoe UI"/>
+              </a:rPr>
+              <a:t>Disease Prediction System  Using Machine Learning</a:t>
+            </a:r>
+          </a:p>
+        </p:txBody>
+      </p:sp>
+      <p:sp>
+        <p:nvSpPr>
+          <p:cNvPr id="9" name="Rounded Rectangle 8"/>
+          <p:cNvSpPr/>
+          <p:nvPr/>
+        </p:nvSpPr>
+        <p:spPr>
+          <a:xfrm>
+            <a:off x="4722876" y="3611880"/>
+            <a:ext cx="2743200" cy="548640"/>
+          </a:xfrm>
+          <a:prstGeom prst="roundRect">
+            <a:avLst/>
+          </a:prstGeom>
+          <a:solidFill>
+            <a:srgbClr val="1E1204"/>
+          </a:solidFill>
+          <a:ln w="17780">
+            <a:solidFill>
+              <a:srgbClr val="FF6B2B"/>
+            </a:solidFill>
+          </a:ln>
+        </p:spPr>
+        <p:style>
+          <a:lnRef idx="1">
+            <a:schemeClr val="accent1"/>
+          </a:lnRef>
+          <a:fillRef idx="3">
+            <a:schemeClr val="accent1"/>
+          </a:fillRef>
+          <a:effectRef idx="2">
+            <a:schemeClr val="accent1"/>
+          </a:effectRef>
+          <a:fontRef idx="minor">
+            <a:schemeClr val="lt1"/>
+          </a:fontRef>
+        </p:style>
+        <p:txBody>
+          <a:bodyPr rtlCol="0" anchor="ctr"/>
+          <a:lstStyle/>
+          <a:p>
+            <a:pPr algn="ctr"/>
+          </a:p>
+        </p:txBody>
+      </p:sp>
+      <p:sp>
+        <p:nvSpPr>
+          <p:cNvPr id="10" name="TextBox 9"/>
+          <p:cNvSpPr txBox="1"/>
+          <p:nvPr/>
+        </p:nvSpPr>
+        <p:spPr>
+          <a:xfrm>
+            <a:off x="4722876" y="3639312"/>
+            <a:ext cx="2743200" cy="457200"/>
+          </a:xfrm>
+          <a:prstGeom prst="rect">
+            <a:avLst/>
+          </a:prstGeom>
+          <a:noFill/>
+        </p:spPr>
+        <p:txBody>
+          <a:bodyPr wrap="square" anchor="ctr">
+            <a:noAutofit/>
+          </a:bodyPr>
+          <a:lstStyle/>
+          <a:p>
+            <a:pPr algn="ctr"/>
+            <a:r>
+              <a:rPr sz="1150" b="1" i="0">
+                <a:solidFill>
+                  <a:srgbClr val="FF6B2B"/>
+                </a:solidFill>
+                <a:latin typeface="Segoe UI"/>
+              </a:rPr>
+              <a:t>★  Best Accuracy: 93.50%  (Stacking Ensemble)</a:t>
+            </a:r>
+          </a:p>
+        </p:txBody>
+      </p:sp>
+      <p:sp>
+        <p:nvSpPr>
+          <p:cNvPr id="11" name="Rounded Rectangle 10"/>
+          <p:cNvSpPr/>
+          <p:nvPr/>
+        </p:nvSpPr>
+        <p:spPr>
+          <a:xfrm>
+            <a:off x="457200" y="4389120"/>
+            <a:ext cx="3575304" cy="877824"/>
+          </a:xfrm>
+          <a:prstGeom prst="roundRect">
+            <a:avLst/>
+          </a:prstGeom>
+          <a:solidFill>
+            <a:srgbClr val="171D2C"/>
+          </a:solidFill>
+          <a:ln w="12700">
+            <a:solidFill>
+              <a:srgbClr val="282F42"/>
+            </a:solidFill>
+          </a:ln>
+        </p:spPr>
+        <p:style>
+          <a:lnRef idx="1">
+            <a:schemeClr val="accent1"/>
+          </a:lnRef>
+          <a:fillRef idx="3">
+            <a:schemeClr val="accent1"/>
+          </a:fillRef>
+          <a:effectRef idx="2">
+            <a:schemeClr val="accent1"/>
+          </a:effectRef>
+          <a:fontRef idx="minor">
+            <a:schemeClr val="lt1"/>
+          </a:fontRef>
+        </p:style>
+        <p:txBody>
+          <a:bodyPr rtlCol="0" anchor="ctr"/>
+          <a:lstStyle/>
+          <a:p>
+            <a:pPr algn="ctr"/>
+          </a:p>
+        </p:txBody>
+      </p:sp>
+      <p:sp>
+        <p:nvSpPr>
+          <p:cNvPr id="12" name="TextBox 11"/>
+          <p:cNvSpPr txBox="1"/>
+          <p:nvPr/>
+        </p:nvSpPr>
+        <p:spPr>
+          <a:xfrm>
+            <a:off x="457200" y="4443984"/>
+            <a:ext cx="3575304" cy="274320"/>
+          </a:xfrm>
+          <a:prstGeom prst="rect">
+            <a:avLst/>
+          </a:prstGeom>
+          <a:noFill/>
+        </p:spPr>
+        <p:txBody>
+          <a:bodyPr wrap="square" anchor="ctr">
+            <a:noAutofit/>
+          </a:bodyPr>
+          <a:lstStyle/>
+          <a:p>
+            <a:pPr algn="ctr"/>
+            <a:r>
+              <a:rPr sz="900" b="1" i="0">
+                <a:solidFill>
+                  <a:srgbClr val="2DCEBF"/>
+                </a:solidFill>
+                <a:latin typeface="Segoe UI Semibold"/>
+              </a:rPr>
+              <a:t>Course</a:t>
+            </a:r>
+          </a:p>
+        </p:txBody>
+      </p:sp>
+      <p:sp>
+        <p:nvSpPr>
+          <p:cNvPr id="13" name="TextBox 12"/>
+          <p:cNvSpPr txBox="1"/>
+          <p:nvPr/>
+        </p:nvSpPr>
+        <p:spPr>
+          <a:xfrm>
+            <a:off x="457200" y="4736592"/>
+            <a:ext cx="3575304" cy="457200"/>
+          </a:xfrm>
+          <a:prstGeom prst="rect">
+            <a:avLst/>
+          </a:prstGeom>
+          <a:noFill/>
+        </p:spPr>
+        <p:txBody>
+          <a:bodyPr wrap="square" anchor="ctr">
+            <a:noAutofit/>
+          </a:bodyPr>
+          <a:lstStyle/>
+          <a:p>
+            <a:pPr algn="ctr"/>
+            <a:r>
+              <a:rPr sz="1050" b="0" i="0">
+                <a:solidFill>
+                  <a:srgbClr val="C8D0DE"/>
+                </a:solidFill>
+                <a:latin typeface="Segoe UI"/>
+              </a:rPr>
+              <a:t>Machine Learning Concept-2  (CSE 3968)</a:t>
+            </a:r>
+          </a:p>
+        </p:txBody>
+      </p:sp>
+      <p:sp>
+        <p:nvSpPr>
+          <p:cNvPr id="14" name="Rounded Rectangle 13"/>
+          <p:cNvSpPr/>
+          <p:nvPr/>
+        </p:nvSpPr>
+        <p:spPr>
+          <a:xfrm>
+            <a:off x="4306824" y="4389120"/>
+            <a:ext cx="3575304" cy="877824"/>
+          </a:xfrm>
+          <a:prstGeom prst="roundRect">
+            <a:avLst/>
+          </a:prstGeom>
+          <a:solidFill>
+            <a:srgbClr val="171D2C"/>
+          </a:solidFill>
+          <a:ln w="12700">
+            <a:solidFill>
+              <a:srgbClr val="282F42"/>
+            </a:solidFill>
+          </a:ln>
+        </p:spPr>
+        <p:style>
+          <a:lnRef idx="1">
+            <a:schemeClr val="accent1"/>
+          </a:lnRef>
+          <a:fillRef idx="3">
+            <a:schemeClr val="accent1"/>
+          </a:fillRef>
+          <a:effectRef idx="2">
+            <a:schemeClr val="accent1"/>
+          </a:effectRef>
+          <a:fontRef idx="minor">
+            <a:schemeClr val="lt1"/>
+          </a:fontRef>
+        </p:style>
+        <p:txBody>
+          <a:bodyPr rtlCol="0" anchor="ctr"/>
+          <a:lstStyle/>
+          <a:p>
+            <a:pPr algn="ctr"/>
+          </a:p>
+        </p:txBody>
+      </p:sp>
+      <p:sp>
+        <p:nvSpPr>
+          <p:cNvPr id="15" name="TextBox 14"/>
+          <p:cNvSpPr txBox="1"/>
+          <p:nvPr/>
+        </p:nvSpPr>
+        <p:spPr>
+          <a:xfrm>
+            <a:off x="4306824" y="4443984"/>
+            <a:ext cx="3575304" cy="274320"/>
+          </a:xfrm>
+          <a:prstGeom prst="rect">
+            <a:avLst/>
+          </a:prstGeom>
+          <a:noFill/>
+        </p:spPr>
+        <p:txBody>
+          <a:bodyPr wrap="square" anchor="ctr">
+            <a:noAutofit/>
+          </a:bodyPr>
+          <a:lstStyle/>
+          <a:p>
+            <a:pPr algn="ctr"/>
+            <a:r>
+              <a:rPr sz="900" b="1" i="0">
+                <a:solidFill>
+                  <a:srgbClr val="FFB330"/>
+                </a:solidFill>
+                <a:latin typeface="Segoe UI Semibold"/>
+              </a:rPr>
+              <a:t>Institute</a:t>
+            </a:r>
+          </a:p>
+        </p:txBody>
+      </p:sp>
+      <p:sp>
+        <p:nvSpPr>
+          <p:cNvPr id="16" name="TextBox 15"/>
+          <p:cNvSpPr txBox="1"/>
+          <p:nvPr/>
+        </p:nvSpPr>
+        <p:spPr>
+          <a:xfrm>
+            <a:off x="4306824" y="4736592"/>
+            <a:ext cx="3575304" cy="457200"/>
+          </a:xfrm>
+          <a:prstGeom prst="rect">
+            <a:avLst/>
+          </a:prstGeom>
+          <a:noFill/>
+        </p:spPr>
+        <p:txBody>
+          <a:bodyPr wrap="square" anchor="ctr">
+            <a:noAutofit/>
+          </a:bodyPr>
+          <a:lstStyle/>
+          <a:p>
+            <a:pPr algn="ctr"/>
+            <a:r>
+              <a:rPr sz="1050" b="0" i="0">
+                <a:solidFill>
+                  <a:srgbClr val="C8D0DE"/>
+                </a:solidFill>
+                <a:latin typeface="Segoe UI"/>
+              </a:rPr>
+              <a:t>ITER, SOA University, Bhubaneswar</a:t>
+            </a:r>
+          </a:p>
+        </p:txBody>
+      </p:sp>
+      <p:sp>
+        <p:nvSpPr>
+          <p:cNvPr id="17" name="Rounded Rectangle 16"/>
+          <p:cNvSpPr/>
+          <p:nvPr/>
+        </p:nvSpPr>
+        <p:spPr>
+          <a:xfrm>
+            <a:off x="8156448" y="4389120"/>
+            <a:ext cx="3575304" cy="877824"/>
+          </a:xfrm>
+          <a:prstGeom prst="roundRect">
+            <a:avLst/>
+          </a:prstGeom>
+          <a:solidFill>
+            <a:srgbClr val="171D2C"/>
+          </a:solidFill>
+          <a:ln w="12700">
+            <a:solidFill>
+              <a:srgbClr val="282F42"/>
+            </a:solidFill>
+          </a:ln>
+        </p:spPr>
+        <p:style>
+          <a:lnRef idx="1">
+            <a:schemeClr val="accent1"/>
+          </a:lnRef>
+          <a:fillRef idx="3">
+            <a:schemeClr val="accent1"/>
+          </a:fillRef>
+          <a:effectRef idx="2">
+            <a:schemeClr val="accent1"/>
+          </a:effectRef>
+          <a:fontRef idx="minor">
+            <a:schemeClr val="lt1"/>
+          </a:fontRef>
+        </p:style>
+        <p:txBody>
+          <a:bodyPr rtlCol="0" anchor="ctr"/>
+          <a:lstStyle/>
+          <a:p>
+            <a:pPr algn="ctr"/>
+          </a:p>
+        </p:txBody>
+      </p:sp>
+      <p:sp>
+        <p:nvSpPr>
+          <p:cNvPr id="18" name="TextBox 17"/>
+          <p:cNvSpPr txBox="1"/>
+          <p:nvPr/>
+        </p:nvSpPr>
+        <p:spPr>
+          <a:xfrm>
+            <a:off x="8156448" y="4443984"/>
+            <a:ext cx="3575304" cy="274320"/>
+          </a:xfrm>
+          <a:prstGeom prst="rect">
+            <a:avLst/>
+          </a:prstGeom>
+          <a:noFill/>
+        </p:spPr>
+        <p:txBody>
+          <a:bodyPr wrap="square" anchor="ctr">
+            <a:noAutofit/>
+          </a:bodyPr>
+          <a:lstStyle/>
+          <a:p>
+            <a:pPr algn="ctr"/>
+            <a:r>
+              <a:rPr sz="900" b="1" i="0">
+                <a:solidFill>
+                  <a:srgbClr val="5BA8FF"/>
+                </a:solidFill>
+                <a:latin typeface="Segoe UI Semibold"/>
+              </a:rPr>
+              <a:t>Year</a:t>
+            </a:r>
+          </a:p>
+        </p:txBody>
+      </p:sp>
+      <p:sp>
+        <p:nvSpPr>
+          <p:cNvPr id="19" name="TextBox 18"/>
+          <p:cNvSpPr txBox="1"/>
+          <p:nvPr/>
+        </p:nvSpPr>
+        <p:spPr>
+          <a:xfrm>
+            <a:off x="8156448" y="4736592"/>
+            <a:ext cx="3575304" cy="457200"/>
+          </a:xfrm>
+          <a:prstGeom prst="rect">
+            <a:avLst/>
+          </a:prstGeom>
+          <a:noFill/>
+        </p:spPr>
+        <p:txBody>
+          <a:bodyPr wrap="square" anchor="ctr">
+            <a:noAutofit/>
+          </a:bodyPr>
+          <a:lstStyle/>
+          <a:p>
+            <a:pPr algn="ctr"/>
+            <a:r>
+              <a:rPr sz="1050" b="0" i="0">
+                <a:solidFill>
+                  <a:srgbClr val="C8D0DE"/>
+                </a:solidFill>
+                <a:latin typeface="Segoe UI"/>
+              </a:rPr>
+              <a:t>May 2026</a:t>
+            </a:r>
+          </a:p>
+        </p:txBody>
+      </p:sp>
+      <p:sp>
+        <p:nvSpPr>
+          <p:cNvPr id="20" name="Rounded Rectangle 19"/>
+          <p:cNvSpPr/>
+          <p:nvPr/>
+        </p:nvSpPr>
+        <p:spPr>
+          <a:xfrm>
+            <a:off x="457200" y="5449824"/>
+            <a:ext cx="11274552" cy="457200"/>
+          </a:xfrm>
+          <a:prstGeom prst="roundRect">
+            <a:avLst/>
+          </a:prstGeom>
+          <a:solidFill>
+            <a:srgbClr val="101828"/>
+          </a:solidFill>
+          <a:ln w="15240">
+            <a:solidFill>
+              <a:srgbClr val="2DCEBF"/>
+            </a:solidFill>
+          </a:ln>
+        </p:spPr>
+        <p:style>
+          <a:lnRef idx="1">
+            <a:schemeClr val="accent1"/>
+          </a:lnRef>
+          <a:fillRef idx="3">
+            <a:schemeClr val="accent1"/>
+          </a:fillRef>
+          <a:effectRef idx="2">
+            <a:schemeClr val="accent1"/>
+          </a:effectRef>
+          <a:fontRef idx="minor">
+            <a:schemeClr val="lt1"/>
+          </a:fontRef>
+        </p:style>
+        <p:txBody>
+          <a:bodyPr rtlCol="0" anchor="ctr"/>
+          <a:lstStyle/>
+          <a:p>
+            <a:pPr algn="ctr"/>
+          </a:p>
+        </p:txBody>
+      </p:sp>
+      <p:sp>
+        <p:nvSpPr>
+          <p:cNvPr id="21" name="TextBox 20"/>
+          <p:cNvSpPr txBox="1"/>
+          <p:nvPr/>
+        </p:nvSpPr>
+        <p:spPr>
+          <a:xfrm>
+            <a:off x="685800" y="5486400"/>
+            <a:ext cx="10817352" cy="365760"/>
+          </a:xfrm>
+          <a:prstGeom prst="rect">
+            <a:avLst/>
+          </a:prstGeom>
+          <a:noFill/>
+        </p:spPr>
+        <p:txBody>
+          <a:bodyPr wrap="square" anchor="ctr">
+            <a:noAutofit/>
+          </a:bodyPr>
+          <a:lstStyle/>
+          <a:p>
+            <a:pPr algn="ctr"/>
+            <a:r>
+              <a:rPr sz="1300" b="1" i="0">
+                <a:solidFill>
+                  <a:srgbClr val="2DCEBF"/>
+                </a:solidFill>
+                <a:latin typeface="Segoe UI"/>
+              </a:rPr>
+              <a:t>We welcome your questions  —  open for discussion</a:t>
+            </a:r>
+          </a:p>
+        </p:txBody>
+      </p:sp>
+      <p:sp>
+        <p:nvSpPr>
+          <p:cNvPr id="22" name="Rectangle 21"/>
+          <p:cNvSpPr/>
+          <p:nvPr/>
+        </p:nvSpPr>
+        <p:spPr>
+          <a:xfrm>
+            <a:off x="0" y="6528816"/>
+            <a:ext cx="12188952" cy="9144"/>
+          </a:xfrm>
+          <a:prstGeom prst="rect">
+            <a:avLst/>
+          </a:prstGeom>
+          <a:solidFill>
+            <a:srgbClr val="282F42"/>
+          </a:solidFill>
+          <a:ln>
+            <a:noFill/>
+          </a:ln>
+        </p:spPr>
+        <p:style>
+          <a:lnRef idx="1">
+            <a:schemeClr val="accent1"/>
+          </a:lnRef>
+          <a:fillRef idx="3">
+            <a:schemeClr val="accent1"/>
+          </a:fillRef>
+          <a:effectRef idx="2">
+            <a:schemeClr val="accent1"/>
+          </a:effectRef>
+          <a:fontRef idx="minor">
+            <a:schemeClr val="lt1"/>
+          </a:fontRef>
+        </p:style>
+        <p:txBody>
+          <a:bodyPr rtlCol="0" anchor="ctr"/>
+          <a:lstStyle/>
+          <a:p>
+            <a:pPr algn="ctr"/>
+          </a:p>
+        </p:txBody>
+      </p:sp>
+      <p:sp>
+        <p:nvSpPr>
+          <p:cNvPr id="23" name="TextBox 22"/>
+          <p:cNvSpPr txBox="1"/>
+          <p:nvPr/>
+        </p:nvSpPr>
+        <p:spPr>
+          <a:xfrm>
+            <a:off x="457200" y="6565392"/>
+            <a:ext cx="5486400" cy="228600"/>
+          </a:xfrm>
+          <a:prstGeom prst="rect">
+            <a:avLst/>
+          </a:prstGeom>
+          <a:noFill/>
+        </p:spPr>
+        <p:txBody>
+          <a:bodyPr wrap="square" anchor="ctr">
+            <a:noAutofit/>
+          </a:bodyPr>
+          <a:lstStyle/>
+          <a:p>
+            <a:pPr algn="l"/>
+            <a:r>
+              <a:rPr sz="750" b="0" i="0">
+                <a:solidFill>
+                  <a:srgbClr val="8A94A6"/>
+                </a:solidFill>
+                <a:latin typeface="Segoe UI"/>
+              </a:rPr>
+              <a:t>Disease Prediction System  ·  Using Machine Learning</a:t>
+            </a:r>
+          </a:p>
+        </p:txBody>
+      </p:sp>
+      <p:sp>
+        <p:nvSpPr>
+          <p:cNvPr id="24" name="TextBox 23"/>
+          <p:cNvSpPr txBox="1"/>
+          <p:nvPr/>
+        </p:nvSpPr>
+        <p:spPr>
+          <a:xfrm>
+            <a:off x="7159752" y="6565392"/>
+            <a:ext cx="4572000" cy="228600"/>
+          </a:xfrm>
+          <a:prstGeom prst="rect">
+            <a:avLst/>
+          </a:prstGeom>
+          <a:noFill/>
+        </p:spPr>
+        <p:txBody>
+          <a:bodyPr wrap="square" anchor="ctr">
+            <a:noAutofit/>
+          </a:bodyPr>
+          <a:lstStyle/>
+          <a:p>
+            <a:pPr algn="r"/>
+            <a:r>
+              <a:rPr sz="750" b="0" i="0">
+                <a:solidFill>
+                  <a:srgbClr val="8A94A6"/>
+                </a:solidFill>
+                <a:latin typeface="Segoe UI"/>
+              </a:rPr>
+              <a:t>MLC-2  |  CSE 3968  |  ITER, SOA University  |  May 2026</a:t>
+            </a:r>
+          </a:p>
+        </p:txBody>
+      </p:sp>
+    </p:spTree>
+  </p:cSld>
+  <p:clrMapOvr>
+    <a:masterClrMapping/>
+  </p:clrMapOvr>
+  <p:timing>
+    <p:tnLst>
+      <p:par>
+        <p:cTn id="101" dur="indefinite" restart="whenNotActive" nodeType="tmRoot">
+          <p:childTnLst>
+            <p:seq concurrent="1" nextAc="seek">
+              <p:cTn id="102" dur="indefinite" nodeType="mainSeq">
+                <p:childTnLst>
+                  <p:par>
+                    <p:cTn id="103" fill="hold" nodeType="afterEffect">
+                      <p:stCondLst>
+                        <p:cond delay="0"/>
+                      </p:stCondLst>
+                      <p:childTnLst>
+                        <p:par>
+                          <p:cTn id="104" fill="hold">
+                            <p:stCondLst>
+                              <p:cond delay="0"/>
+                            </p:stCondLst>
+                            <p:childTnLst>
+                              <p:par>
+                                <p:cTn id="105" presetID="10" presetClass="entr" presetSubtype="0" fill="hold" grpId="0" nodeType="withEffect">
+                                  <p:stCondLst>
+                                    <p:cond delay="0"/>
+                                  </p:stCondLst>
+                                  <p:childTnLst>
+                                    <p:animEffect transition="in" filter="fade">
+                                      <p:cBhvr>
+                                        <p:cTn id="106" dur="700">
+                                          <p:stCondLst>
+                                            <p:cond delay="0"/>
+                                          </p:stCondLst>
+                                        </p:cTn>
+                                        <p:tgtEl>
+                                          <p:spTgt spid="6"/>
+                                        </p:tgtEl>
+                                      </p:cBhvr>
+                                    </p:animEffect>
+                                  </p:childTnLst>
+                                </p:cTn>
+                              </p:par>
+                            </p:childTnLst>
+                          </p:cTn>
+                        </p:par>
+                      </p:childTnLst>
+                    </p:cTn>
+                  </p:par>
+                  <p:par>
+                    <p:cTn id="107" fill="hold" nodeType="afterEffect">
+                      <p:stCondLst>
+                        <p:cond delay="300"/>
+                      </p:stCondLst>
+                      <p:childTnLst>
+                        <p:par>
+                          <p:cTn id="108" fill="hold">
+                            <p:stCondLst>
+                              <p:cond delay="0"/>
+                            </p:stCondLst>
+                            <p:childTnLst>
+                              <p:par>
+                                <p:cTn id="109" presetID="10" presetClass="entr" presetSubtype="0" fill="hold" grpId="0" nodeType="withEffect">
+                                  <p:stCondLst>
+                                    <p:cond delay="0"/>
+                                  </p:stCondLst>
+                                  <p:childTnLst>
+                                    <p:animEffect transition="in" filter="fade">
+                                      <p:cBhvr>
+                                        <p:cTn id="110" dur="400">
+                                          <p:stCondLst>
+                                            <p:cond delay="0"/>
+                                          </p:stCondLst>
+                                        </p:cTn>
+                                        <p:tgtEl>
+                                          <p:spTgt spid="7"/>
+                                        </p:tgtEl>
+                                      </p:cBhvr>
+                                    </p:animEffect>
+                                  </p:childTnLst>
+                                </p:cTn>
+                              </p:par>
+                            </p:childTnLst>
+                          </p:cTn>
+                        </p:par>
+                      </p:childTnLst>
+                    </p:cTn>
+                  </p:par>
+                  <p:par>
+                    <p:cTn id="111" fill="hold" nodeType="afterEffect">
+                      <p:stCondLst>
+                        <p:cond delay="450"/>
+                      </p:stCondLst>
+                      <p:childTnLst>
+                        <p:par>
+                          <p:cTn id="112" fill="hold">
+                            <p:stCondLst>
+                              <p:cond delay="0"/>
+                            </p:stCondLst>
+                            <p:childTnLst>
+                              <p:par>
+                                <p:cTn id="113" presetID="10" presetClass="entr" presetSubtype="0" fill="hold" grpId="0" nodeType="withEffect">
+                                  <p:stCondLst>
+                                    <p:cond delay="0"/>
+                                  </p:stCondLst>
+                                  <p:childTnLst>
+                                    <p:animEffect transition="in" filter="fade">
+                                      <p:cBhvr>
+                                        <p:cTn id="114" dur="500">
+                                          <p:stCondLst>
+                                            <p:cond delay="0"/>
+                                          </p:stCondLst>
+                                        </p:cTn>
+                                        <p:tgtEl>
+                                          <p:spTgt spid="8"/>
+                                        </p:tgtEl>
+                                      </p:cBhvr>
+                                    </p:animEffect>
+                                  </p:childTnLst>
+                                </p:cTn>
+                              </p:par>
+                            </p:childTnLst>
+                          </p:cTn>
+                        </p:par>
+                      </p:childTnLst>
+                    </p:cTn>
+                  </p:par>
+                  <p:par>
+                    <p:cTn id="115" fill="hold" nodeType="afterEffect">
+                      <p:stCondLst>
+                        <p:cond delay="550"/>
+                      </p:stCondLst>
+                      <p:childTnLst>
+                        <p:par>
+                          <p:cTn id="116" fill="hold">
+                            <p:stCondLst>
+                              <p:cond delay="0"/>
+                            </p:stCondLst>
+                            <p:childTnLst>
+                              <p:par>
+                                <p:cTn id="117" presetID="10" presetClass="entr" presetSubtype="0" fill="hold" grpId="0" nodeType="withEffect">
+                                  <p:stCondLst>
+                                    <p:cond delay="0"/>
+                                  </p:stCondLst>
+                                  <p:childTnLst>
+                                    <p:animEffect transition="in" filter="fade">
+                                      <p:cBhvr>
+                                        <p:cTn id="118" dur="450">
+                                          <p:stCondLst>
+                                            <p:cond delay="0"/>
+                                          </p:stCondLst>
+                                        </p:cTn>
+                                        <p:tgtEl>
+                                          <p:spTgt spid="9"/>
+                                        </p:tgtEl>
+                                      </p:cBhvr>
+                                    </p:animEffect>
+                                  </p:childTnLst>
+                                </p:cTn>
+                              </p:par>
+                            </p:childTnLst>
+                          </p:cTn>
+                        </p:par>
+                      </p:childTnLst>
+                    </p:cTn>
+                  </p:par>
+                  <p:par>
+                    <p:cTn id="119" fill="hold" nodeType="afterEffect">
+                      <p:stCondLst>
+                        <p:cond delay="650"/>
+                      </p:stCondLst>
+                      <p:childTnLst>
+                        <p:par>
+                          <p:cTn id="120" fill="hold">
+                            <p:stCondLst>
+                              <p:cond delay="0"/>
+                            </p:stCondLst>
+                            <p:childTnLst>
+                              <p:par>
+                                <p:cTn id="121" presetID="10" presetClass="entr" presetSubtype="0" fill="hold" grpId="0" nodeType="withEffect">
+                                  <p:stCondLst>
+                                    <p:cond delay="0"/>
+                                  </p:stCondLst>
+                                  <p:childTnLst>
+                                    <p:animEffect transition="in" filter="fade">
+                                      <p:cBhvr>
+                                        <p:cTn id="122" dur="430">
+                                          <p:stCondLst>
+                                            <p:cond delay="0"/>
+                                          </p:stCondLst>
+                                        </p:cTn>
+                                        <p:tgtEl>
+                                          <p:spTgt spid="11"/>
+                                        </p:tgtEl>
+                                      </p:cBhvr>
+                                    </p:animEffect>
+                                  </p:childTnLst>
+                                </p:cTn>
+                              </p:par>
+                            </p:childTnLst>
+                          </p:cTn>
+                        </p:par>
+                      </p:childTnLst>
+                    </p:cTn>
+                  </p:par>
+                  <p:par>
+                    <p:cTn id="123" fill="hold" nodeType="afterEffect">
+                      <p:stCondLst>
+                        <p:cond delay="770"/>
+                      </p:stCondLst>
+                      <p:childTnLst>
+                        <p:par>
+                          <p:cTn id="124" fill="hold">
+                            <p:stCondLst>
+                              <p:cond delay="0"/>
+                            </p:stCondLst>
+                            <p:childTnLst>
+                              <p:par>
+                                <p:cTn id="125" presetID="10" presetClass="entr" presetSubtype="0" fill="hold" grpId="0" nodeType="withEffect">
+                                  <p:stCondLst>
+                                    <p:cond delay="0"/>
+                                  </p:stCondLst>
+                                  <p:childTnLst>
+                                    <p:animEffect transition="in" filter="fade">
+                                      <p:cBhvr>
+                                        <p:cTn id="126" dur="430">
+                                          <p:stCondLst>
+                                            <p:cond delay="0"/>
+                                          </p:stCondLst>
+                                        </p:cTn>
+                                        <p:tgtEl>
+                                          <p:spTgt spid="14"/>
+                                        </p:tgtEl>
+                                      </p:cBhvr>
+                                    </p:animEffect>
+                                  </p:childTnLst>
+                                </p:cTn>
+                              </p:par>
+                            </p:childTnLst>
+                          </p:cTn>
+                        </p:par>
+                      </p:childTnLst>
+                    </p:cTn>
+                  </p:par>
+                  <p:par>
+                    <p:cTn id="127" fill="hold" nodeType="afterEffect">
+                      <p:stCondLst>
+                        <p:cond delay="890"/>
+                      </p:stCondLst>
+                      <p:childTnLst>
+                        <p:par>
+                          <p:cTn id="128" fill="hold">
+                            <p:stCondLst>
+                              <p:cond delay="0"/>
+                            </p:stCondLst>
+                            <p:childTnLst>
+                              <p:par>
+                                <p:cTn id="129" presetID="10" presetClass="entr" presetSubtype="0" fill="hold" grpId="0" nodeType="withEffect">
+                                  <p:stCondLst>
+                                    <p:cond delay="0"/>
+                                  </p:stCondLst>
+                                  <p:childTnLst>
+                                    <p:animEffect transition="in" filter="fade">
+                                      <p:cBhvr>
+                                        <p:cTn id="130" dur="430">
+                                          <p:stCondLst>
+                                            <p:cond delay="0"/>
+                                          </p:stCondLst>
+                                        </p:cTn>
+                                        <p:tgtEl>
+                                          <p:spTgt spid="17"/>
+                                        </p:tgtEl>
+                                      </p:cBhvr>
+                                    </p:animEffect>
+                                  </p:childTnLst>
+                                </p:cTn>
+                              </p:par>
+                            </p:childTnLst>
+                          </p:cTn>
+                        </p:par>
+                      </p:childTnLst>
+                    </p:cTn>
+                  </p:par>
+                  <p:par>
+                    <p:cTn id="131" fill="hold" nodeType="afterEffect">
+                      <p:stCondLst>
+                        <p:cond delay="900"/>
+                      </p:stCondLst>
+                      <p:childTnLst>
+                        <p:par>
+                          <p:cTn id="132" fill="hold">
+                            <p:stCondLst>
+                              <p:cond delay="0"/>
+                            </p:stCondLst>
+                            <p:childTnLst>
+                              <p:par>
+                                <p:cTn id="133" presetID="10" presetClass="entr" presetSubtype="0" fill="hold" grpId="0" nodeType="withEffect">
+                                  <p:stCondLst>
+                                    <p:cond delay="0"/>
+                                  </p:stCondLst>
+                                  <p:childTnLst>
+                                    <p:animEffect transition="in" filter="fade">
+                                      <p:cBhvr>
+                                        <p:cTn id="134" dur="450">
+                                          <p:stCondLst>
+                                            <p:cond delay="0"/>
+                                          </p:stCondLst>
+                                        </p:cTn>
+                                        <p:tgtEl>
+                                          <p:spTgt spid="20"/>
+                                        </p:tgtEl>
+                                      </p:cBhvr>
+                                    </p:animEffect>
+                                  </p:childTnLst>
+                                </p:cTn>
+                              </p:par>
+                            </p:childTnLst>
+                          </p:cTn>
+                        </p:par>
+                      </p:childTnLst>
+                    </p:cTn>
+                  </p:par>
+                </p:childTnLst>
+              </p:cTn>
+              <p:nextCondLst>
+                <p:cond evt="onClick" delay="0">
+                  <p:tn val="102"/>
+                </p:cond>
+              </p:nextCondLst>
+            </p:seq>
+          </p:childTnLst>
+        </p:cTn>
+      </p:par>
+    </p:tnLst>
+  </p:timing>
+  <p:transition dur="1000">
+    <p:fade thruBlk="0"/>
+  </p:transition>
+</p:sld>
+</file>
+
 <file path=ppt/slides/slide2.xml><?xml version="1.0" encoding="utf-8"?>
 <p:sld xmlns:a="http://schemas.openxmlformats.org/drawingml/2006/main" xmlns:p="http://schemas.openxmlformats.org/presentationml/2006/main" xmlns:r="http://schemas.openxmlformats.org/officeDocument/2006/relationships">
   <p:cSld>

</xml_diff>